<commit_message>
fix(chips): show error on save failure + preserve optimistic state
</commit_message>
<xml_diff>
--- a/N-Click_가이드.pptx
+++ b/N-Click_가이드.pptx
@@ -312,7 +312,7 @@
           <a:p>
             <a:fld id="{5BCAD085-E8A6-8845-BD4E-CB4CCA059FC4}" type="datetimeFigureOut">
               <a:rPr lang="en-US" smtClean="0"/>
-              <a:t>5/7/2026</a:t>
+              <a:t>5/11/2026</a:t>
             </a:fld>
             <a:endParaRPr lang="en-US"/>
           </a:p>
@@ -480,7 +480,7 @@
           <a:p>
             <a:fld id="{5BCAD085-E8A6-8845-BD4E-CB4CCA059FC4}" type="datetimeFigureOut">
               <a:rPr lang="en-US" smtClean="0"/>
-              <a:t>5/7/2026</a:t>
+              <a:t>5/11/2026</a:t>
             </a:fld>
             <a:endParaRPr lang="en-US"/>
           </a:p>
@@ -658,7 +658,7 @@
           <a:p>
             <a:fld id="{5BCAD085-E8A6-8845-BD4E-CB4CCA059FC4}" type="datetimeFigureOut">
               <a:rPr lang="en-US" smtClean="0"/>
-              <a:t>5/7/2026</a:t>
+              <a:t>5/11/2026</a:t>
             </a:fld>
             <a:endParaRPr lang="en-US"/>
           </a:p>
@@ -826,7 +826,7 @@
           <a:p>
             <a:fld id="{5BCAD085-E8A6-8845-BD4E-CB4CCA059FC4}" type="datetimeFigureOut">
               <a:rPr lang="en-US" smtClean="0"/>
-              <a:t>5/7/2026</a:t>
+              <a:t>5/11/2026</a:t>
             </a:fld>
             <a:endParaRPr lang="en-US"/>
           </a:p>
@@ -1071,7 +1071,7 @@
           <a:p>
             <a:fld id="{5BCAD085-E8A6-8845-BD4E-CB4CCA059FC4}" type="datetimeFigureOut">
               <a:rPr lang="en-US" smtClean="0"/>
-              <a:t>5/7/2026</a:t>
+              <a:t>5/11/2026</a:t>
             </a:fld>
             <a:endParaRPr lang="en-US"/>
           </a:p>
@@ -1356,7 +1356,7 @@
           <a:p>
             <a:fld id="{5BCAD085-E8A6-8845-BD4E-CB4CCA059FC4}" type="datetimeFigureOut">
               <a:rPr lang="en-US" smtClean="0"/>
-              <a:t>5/7/2026</a:t>
+              <a:t>5/11/2026</a:t>
             </a:fld>
             <a:endParaRPr lang="en-US"/>
           </a:p>
@@ -1775,7 +1775,7 @@
           <a:p>
             <a:fld id="{5BCAD085-E8A6-8845-BD4E-CB4CCA059FC4}" type="datetimeFigureOut">
               <a:rPr lang="en-US" smtClean="0"/>
-              <a:t>5/7/2026</a:t>
+              <a:t>5/11/2026</a:t>
             </a:fld>
             <a:endParaRPr lang="en-US"/>
           </a:p>
@@ -1892,7 +1892,7 @@
           <a:p>
             <a:fld id="{5BCAD085-E8A6-8845-BD4E-CB4CCA059FC4}" type="datetimeFigureOut">
               <a:rPr lang="en-US" smtClean="0"/>
-              <a:t>5/7/2026</a:t>
+              <a:t>5/11/2026</a:t>
             </a:fld>
             <a:endParaRPr lang="en-US"/>
           </a:p>
@@ -1987,7 +1987,7 @@
           <a:p>
             <a:fld id="{5BCAD085-E8A6-8845-BD4E-CB4CCA059FC4}" type="datetimeFigureOut">
               <a:rPr lang="en-US" smtClean="0"/>
-              <a:t>5/7/2026</a:t>
+              <a:t>5/11/2026</a:t>
             </a:fld>
             <a:endParaRPr lang="en-US"/>
           </a:p>
@@ -2262,7 +2262,7 @@
           <a:p>
             <a:fld id="{5BCAD085-E8A6-8845-BD4E-CB4CCA059FC4}" type="datetimeFigureOut">
               <a:rPr lang="en-US" smtClean="0"/>
-              <a:t>5/7/2026</a:t>
+              <a:t>5/11/2026</a:t>
             </a:fld>
             <a:endParaRPr lang="en-US"/>
           </a:p>
@@ -2514,7 +2514,7 @@
           <a:p>
             <a:fld id="{5BCAD085-E8A6-8845-BD4E-CB4CCA059FC4}" type="datetimeFigureOut">
               <a:rPr lang="en-US" smtClean="0"/>
-              <a:t>5/7/2026</a:t>
+              <a:t>5/11/2026</a:t>
             </a:fld>
             <a:endParaRPr lang="en-US"/>
           </a:p>
@@ -2725,7 +2725,7 @@
           <a:p>
             <a:fld id="{5BCAD085-E8A6-8845-BD4E-CB4CCA059FC4}" type="datetimeFigureOut">
               <a:rPr lang="en-US" smtClean="0"/>
-              <a:t>5/7/2026</a:t>
+              <a:t>5/11/2026</a:t>
             </a:fld>
             <a:endParaRPr lang="en-US"/>
           </a:p>
@@ -7802,7 +7802,7 @@
         <p:spPr>
           <a:xfrm>
             <a:off x="914400" y="3200400"/>
-            <a:ext cx="4910328" cy="868680"/>
+            <a:ext cx="4910328" cy="224677"/>
           </a:xfrm>
           <a:prstGeom prst="rect">
             <a:avLst/>
@@ -7821,13 +7821,175 @@
               </a:lnSpc>
             </a:pPr>
             <a:r>
+              <a:rPr sz="1100" b="0" dirty="0">
+                <a:solidFill>
+                  <a:srgbClr val="64748B"/>
+                </a:solidFill>
+                <a:latin typeface="Pretendard"/>
+              </a:rPr>
+              <a:t>MY PAGE </a:t>
+            </a:r>
+            <a:r>
+              <a:rPr sz="1100" b="0" dirty="0" err="1">
+                <a:solidFill>
+                  <a:srgbClr val="64748B"/>
+                </a:solidFill>
+                <a:latin typeface="Pretendard"/>
+              </a:rPr>
+              <a:t>헤더의</a:t>
+            </a:r>
+            <a:r>
+              <a:rPr sz="1100" b="0" dirty="0">
+                <a:solidFill>
+                  <a:srgbClr val="64748B"/>
+                </a:solidFill>
+                <a:latin typeface="Pretendard"/>
+              </a:rPr>
+              <a:t> </a:t>
+            </a:r>
+            <a:r>
+              <a:rPr sz="1100" b="0" dirty="0" err="1">
+                <a:solidFill>
+                  <a:srgbClr val="64748B"/>
+                </a:solidFill>
+                <a:latin typeface="Pretendard"/>
+              </a:rPr>
+              <a:t>날짜</a:t>
+            </a:r>
+            <a:r>
+              <a:rPr sz="1100" b="0" dirty="0">
+                <a:solidFill>
+                  <a:srgbClr val="64748B"/>
+                </a:solidFill>
+                <a:latin typeface="Pretendard"/>
+              </a:rPr>
+              <a:t> </a:t>
+            </a:r>
+            <a:r>
+              <a:rPr sz="1100" b="0" err="1">
+                <a:solidFill>
+                  <a:srgbClr val="64748B"/>
+                </a:solidFill>
+                <a:latin typeface="Pretendard"/>
+              </a:rPr>
+              <a:t>좌측</a:t>
+            </a:r>
+            <a:r>
               <a:rPr sz="1100" b="0">
                 <a:solidFill>
                   <a:srgbClr val="64748B"/>
                 </a:solidFill>
                 <a:latin typeface="Pretendard"/>
               </a:rPr>
-              <a:t>MY PAGE 헤더의 날짜 좌측 chevron(&lt;)으로 어제 날짜로 이동 → 평소처럼 보고.</a:t>
+              <a:t> </a:t>
+            </a:r>
+            <a:r>
+              <a:rPr lang="ko-KR" altLang="en-US" sz="1100">
+                <a:solidFill>
+                  <a:srgbClr val="64748B"/>
+                </a:solidFill>
+                <a:latin typeface="Pretendard"/>
+              </a:rPr>
+              <a:t>버튼</a:t>
+            </a:r>
+            <a:r>
+              <a:rPr sz="1100" b="0">
+                <a:solidFill>
+                  <a:srgbClr val="64748B"/>
+                </a:solidFill>
+                <a:latin typeface="Pretendard"/>
+              </a:rPr>
+              <a:t>으로 </a:t>
+            </a:r>
+            <a:r>
+              <a:rPr sz="1100" b="0" dirty="0" err="1">
+                <a:solidFill>
+                  <a:srgbClr val="64748B"/>
+                </a:solidFill>
+                <a:latin typeface="Pretendard"/>
+              </a:rPr>
+              <a:t>어제</a:t>
+            </a:r>
+            <a:r>
+              <a:rPr sz="1100" b="0" dirty="0">
+                <a:solidFill>
+                  <a:srgbClr val="64748B"/>
+                </a:solidFill>
+                <a:latin typeface="Pretendard"/>
+              </a:rPr>
+              <a:t> </a:t>
+            </a:r>
+            <a:r>
+              <a:rPr sz="1100" b="0" dirty="0" err="1">
+                <a:solidFill>
+                  <a:srgbClr val="64748B"/>
+                </a:solidFill>
+                <a:latin typeface="Pretendard"/>
+              </a:rPr>
+              <a:t>날짜로</a:t>
+            </a:r>
+            <a:r>
+              <a:rPr sz="1100" b="0" dirty="0">
+                <a:solidFill>
+                  <a:srgbClr val="64748B"/>
+                </a:solidFill>
+                <a:latin typeface="Pretendard"/>
+              </a:rPr>
+              <a:t> </a:t>
+            </a:r>
+            <a:r>
+              <a:rPr sz="1100" b="0" dirty="0" err="1">
+                <a:solidFill>
+                  <a:srgbClr val="64748B"/>
+                </a:solidFill>
+                <a:latin typeface="Pretendard"/>
+              </a:rPr>
+              <a:t>이동</a:t>
+            </a:r>
+            <a:r>
+              <a:rPr sz="1100" b="0" dirty="0">
+                <a:solidFill>
+                  <a:srgbClr val="64748B"/>
+                </a:solidFill>
+                <a:latin typeface="Pretendard"/>
+              </a:rPr>
+              <a:t> → </a:t>
+            </a:r>
+            <a:r>
+              <a:rPr sz="1100" b="0" dirty="0" err="1">
+                <a:solidFill>
+                  <a:srgbClr val="64748B"/>
+                </a:solidFill>
+                <a:latin typeface="Pretendard"/>
+              </a:rPr>
+              <a:t>평소처럼</a:t>
+            </a:r>
+            <a:r>
+              <a:rPr sz="1100" b="0" dirty="0">
+                <a:solidFill>
+                  <a:srgbClr val="64748B"/>
+                </a:solidFill>
+                <a:latin typeface="Pretendard"/>
+              </a:rPr>
+              <a:t> </a:t>
+            </a:r>
+            <a:r>
+              <a:rPr sz="1100" b="0" dirty="0" err="1">
+                <a:solidFill>
+                  <a:srgbClr val="64748B"/>
+                </a:solidFill>
+                <a:latin typeface="Pretendard"/>
+              </a:rPr>
+              <a:t>보고</a:t>
+            </a:r>
+            <a:r>
+              <a:rPr sz="1100" b="0" dirty="0">
+                <a:solidFill>
+                  <a:srgbClr val="64748B"/>
+                </a:solidFill>
+                <a:latin typeface="Pretendard"/>
+              </a:rPr>
+              <a:t>.</a:t>
             </a:r>
           </a:p>
         </p:txBody>
@@ -9071,7 +9233,7 @@
                 <a:ea typeface="Pretendard" panose="02000503000000020004" pitchFamily="50" charset="-127"/>
                 <a:cs typeface="Pretendard" panose="02000503000000020004" pitchFamily="50" charset="-127"/>
               </a:rPr>
-              <a:t xml:space="preserve"> 시 </a:t>
+              <a:t> 시 </a:t>
             </a:r>
             <a:r>
               <a:rPr sz="1200" dirty="0" err="1">
@@ -9093,7 +9255,7 @@
                 <a:ea typeface="Pretendard" panose="02000503000000020004" pitchFamily="50" charset="-127"/>
                 <a:cs typeface="Pretendard" panose="02000503000000020004" pitchFamily="50" charset="-127"/>
               </a:rPr>
-              <a:t xml:space="preserve"> </a:t>
+              <a:t> </a:t>
             </a:r>
             <a:r>
               <a:rPr sz="1200" dirty="0" err="1">
@@ -9115,7 +9277,7 @@
                 <a:ea typeface="Pretendard" panose="02000503000000020004" pitchFamily="50" charset="-127"/>
                 <a:cs typeface="Pretendard" panose="02000503000000020004" pitchFamily="50" charset="-127"/>
               </a:rPr>
-              <a:t xml:space="preserve"> 09시로 </a:t>
+              <a:t> 09시로 </a:t>
             </a:r>
             <a:r>
               <a:rPr sz="1200" dirty="0" err="1">
@@ -9137,7 +9299,7 @@
                 <a:ea typeface="Pretendard" panose="02000503000000020004" pitchFamily="50" charset="-127"/>
                 <a:cs typeface="Pretendard" panose="02000503000000020004" pitchFamily="50" charset="-127"/>
               </a:rPr>
-              <a:t xml:space="preserve"> </a:t>
+              <a:t> </a:t>
             </a:r>
             <a:r>
               <a:rPr sz="1200" dirty="0" err="1">
@@ -9159,7 +9321,7 @@
                 <a:ea typeface="Pretendard" panose="02000503000000020004" pitchFamily="50" charset="-127"/>
                 <a:cs typeface="Pretendard" panose="02000503000000020004" pitchFamily="50" charset="-127"/>
               </a:rPr>
-              <a:t xml:space="preserve"> </a:t>
+              <a:t> </a:t>
             </a:r>
             <a:r>
               <a:rPr sz="1200" dirty="0" err="1">
@@ -9181,7 +9343,7 @@
                 <a:ea typeface="Pretendard" panose="02000503000000020004" pitchFamily="50" charset="-127"/>
                 <a:cs typeface="Pretendard" panose="02000503000000020004" pitchFamily="50" charset="-127"/>
               </a:rPr>
-              <a:t xml:space="preserve"> </a:t>
+              <a:t> </a:t>
             </a:r>
             <a:r>
               <a:rPr sz="1200" dirty="0" err="1">
@@ -9214,7 +9376,7 @@
                 <a:ea typeface="Pretendard" panose="02000503000000020004" pitchFamily="50" charset="-127"/>
                 <a:cs typeface="Pretendard" panose="02000503000000020004" pitchFamily="50" charset="-127"/>
               </a:rPr>
-              <a:t xml:space="preserve">, </a:t>
+              <a:t>, </a:t>
             </a:r>
             <a:r>
               <a:rPr sz="1200" dirty="0" err="1">
@@ -9236,7 +9398,7 @@
                 <a:ea typeface="Pretendard" panose="02000503000000020004" pitchFamily="50" charset="-127"/>
                 <a:cs typeface="Pretendard" panose="02000503000000020004" pitchFamily="50" charset="-127"/>
               </a:rPr>
-              <a:t xml:space="preserve"> </a:t>
+              <a:t> </a:t>
             </a:r>
             <a:r>
               <a:rPr sz="1200" dirty="0" err="1">
@@ -9258,7 +9420,7 @@
                 <a:ea typeface="Pretendard" panose="02000503000000020004" pitchFamily="50" charset="-127"/>
                 <a:cs typeface="Pretendard" panose="02000503000000020004" pitchFamily="50" charset="-127"/>
               </a:rPr>
-              <a:t xml:space="preserve"> </a:t>
+              <a:t> </a:t>
             </a:r>
             <a:r>
               <a:rPr sz="1200" dirty="0" err="1">
@@ -9280,7 +9442,7 @@
                 <a:ea typeface="Pretendard" panose="02000503000000020004" pitchFamily="50" charset="-127"/>
                 <a:cs typeface="Pretendard" panose="02000503000000020004" pitchFamily="50" charset="-127"/>
               </a:rPr>
-              <a:t xml:space="preserve"> </a:t>
+              <a:t> </a:t>
             </a:r>
             <a:r>
               <a:rPr sz="1200" dirty="0" err="1">
@@ -9520,7 +9682,7 @@
                 </a:solidFill>
                 <a:latin typeface="Pretendard"/>
               </a:rPr>
-              <a:t xml:space="preserve"> </a:t>
+              <a:t> </a:t>
             </a:r>
             <a:r>
               <a:rPr sz="1200" b="0" dirty="0" err="1">
@@ -9538,7 +9700,7 @@
                 </a:solidFill>
                 <a:latin typeface="Pretendard"/>
               </a:rPr>
-              <a:t xml:space="preserve"> </a:t>
+              <a:t> </a:t>
             </a:r>
             <a:r>
               <a:rPr sz="1200" b="0" dirty="0" err="1">
@@ -9556,7 +9718,7 @@
                 </a:solidFill>
                 <a:latin typeface="Pretendard"/>
               </a:rPr>
-              <a:t xml:space="preserve"> </a:t>
+              <a:t> </a:t>
             </a:r>
             <a:r>
               <a:rPr sz="1200" b="0" dirty="0" err="1">
@@ -9574,7 +9736,7 @@
                 </a:solidFill>
                 <a:latin typeface="Pretendard"/>
               </a:rPr>
-              <a:t xml:space="preserve">, </a:t>
+              <a:t>, </a:t>
             </a:r>
             <a:r>
               <a:rPr sz="1200" b="0" dirty="0" err="1">
@@ -9610,7 +9772,7 @@
                 </a:solidFill>
                 <a:latin typeface="Pretendard"/>
               </a:rPr>
-              <a:t xml:space="preserve"> </a:t>
+              <a:t> </a:t>
             </a:r>
             <a:r>
               <a:rPr sz="1200" b="0" dirty="0" err="1">
@@ -9628,7 +9790,7 @@
                 </a:solidFill>
                 <a:latin typeface="Pretendard"/>
               </a:rPr>
-              <a:t xml:space="preserve"> </a:t>
+              <a:t> </a:t>
             </a:r>
             <a:r>
               <a:rPr sz="1200" b="0" dirty="0" err="1">
@@ -9646,7 +9808,7 @@
                 </a:solidFill>
                 <a:latin typeface="Pretendard"/>
               </a:rPr>
-              <a:t xml:space="preserve"> </a:t>
+              <a:t> </a:t>
             </a:r>
             <a:r>
               <a:rPr sz="1200" b="0" dirty="0" err="1">
@@ -9664,7 +9826,7 @@
                 </a:solidFill>
                 <a:latin typeface="Pretendard"/>
               </a:rPr>
-              <a:t xml:space="preserve"> </a:t>
+              <a:t> </a:t>
             </a:r>
             <a:r>
               <a:rPr sz="1200" b="0" dirty="0" err="1">
@@ -9682,7 +9844,7 @@
                 </a:solidFill>
                 <a:latin typeface="Pretendard"/>
               </a:rPr>
-              <a:t xml:space="preserve"> </a:t>
+              <a:t> </a:t>
             </a:r>
             <a:r>
               <a:rPr sz="1200" b="0" dirty="0" err="1">
@@ -9700,7 +9862,7 @@
                 </a:solidFill>
                 <a:latin typeface="Pretendard"/>
               </a:rPr>
-              <a:t xml:space="preserve"> </a:t>
+              <a:t> </a:t>
             </a:r>
             <a:r>
               <a:rPr sz="1200" b="0" dirty="0" err="1">
@@ -9718,7 +9880,7 @@
                 </a:solidFill>
                 <a:latin typeface="Pretendard"/>
               </a:rPr>
-              <a:t xml:space="preserve"> </a:t>
+              <a:t> </a:t>
             </a:r>
             <a:r>
               <a:rPr sz="1200" b="0" dirty="0" err="1">
@@ -13911,8 +14073,8 @@
         </p:nvSpPr>
         <p:spPr>
           <a:xfrm>
-            <a:off x="1234440" y="4663440"/>
-            <a:ext cx="2011680" cy="292608"/>
+            <a:off x="1234440" y="4724945"/>
+            <a:ext cx="2011680" cy="169598"/>
           </a:xfrm>
           <a:prstGeom prst="rect">
             <a:avLst/>
@@ -13931,14 +14093,29 @@
               </a:lnSpc>
             </a:pPr>
             <a:r>
-              <a:rPr sz="1000" b="1">
+              <a:rPr sz="1000" b="1" dirty="0" err="1">
                 <a:solidFill>
                   <a:srgbClr val="2563EB"/>
                 </a:solidFill>
                 <a:latin typeface="Pretendard"/>
               </a:rPr>
-              <a:t>출근완료 대기</a:t>
-            </a:r>
+              <a:t>출근</a:t>
+            </a:r>
+            <a:r>
+              <a:rPr lang="ko-KR" altLang="en-US" sz="1000" b="1" dirty="0">
+                <a:solidFill>
+                  <a:srgbClr val="2563EB"/>
+                </a:solidFill>
+                <a:latin typeface="Pretendard"/>
+              </a:rPr>
+              <a:t>보고 완료</a:t>
+            </a:r>
+            <a:endParaRPr sz="1000" b="1" dirty="0">
+              <a:solidFill>
+                <a:srgbClr val="2563EB"/>
+              </a:solidFill>
+              <a:latin typeface="Pretendard"/>
+            </a:endParaRPr>
           </a:p>
         </p:txBody>
       </p:sp>
@@ -15935,7 +16112,7 @@
               </a:lnSpc>
             </a:pPr>
             <a:r>
-              <a:rPr sz="3400" b="1">
+              <a:rPr sz="3400" b="1" dirty="0" err="1">
                 <a:solidFill>
                   <a:srgbClr val="0F172A"/>
                 </a:solidFill>
@@ -15943,6 +16120,12 @@
               </a:rPr>
               <a:t>출근하기</a:t>
             </a:r>
+            <a:endParaRPr sz="3400" b="1" dirty="0">
+              <a:solidFill>
+                <a:srgbClr val="0F172A"/>
+              </a:solidFill>
+              <a:latin typeface="Pretendard"/>
+            </a:endParaRPr>
           </a:p>
         </p:txBody>
       </p:sp>
@@ -16176,14 +16359,128 @@
               </a:lnSpc>
             </a:pPr>
             <a:r>
-              <a:rPr sz="1400" b="1">
+              <a:rPr sz="1400" b="1" dirty="0" err="1">
                 <a:solidFill>
                   <a:srgbClr val="0F172A"/>
                 </a:solidFill>
                 <a:latin typeface="Pretendard"/>
               </a:rPr>
-              <a:t>출근보고로 예정 등록 → 출근완료로 실제 시각 확정</a:t>
-            </a:r>
+              <a:t>출근보고로</a:t>
+            </a:r>
+            <a:r>
+              <a:rPr sz="1400" b="1" dirty="0">
+                <a:solidFill>
+                  <a:srgbClr val="0F172A"/>
+                </a:solidFill>
+                <a:latin typeface="Pretendard"/>
+              </a:rPr>
+              <a:t> </a:t>
+            </a:r>
+            <a:r>
+              <a:rPr sz="1400" b="1" dirty="0" err="1">
+                <a:solidFill>
+                  <a:srgbClr val="0F172A"/>
+                </a:solidFill>
+                <a:latin typeface="Pretendard"/>
+              </a:rPr>
+              <a:t>예정</a:t>
+            </a:r>
+            <a:r>
+              <a:rPr sz="1400" b="1" dirty="0">
+                <a:solidFill>
+                  <a:srgbClr val="0F172A"/>
+                </a:solidFill>
+                <a:latin typeface="Pretendard"/>
+              </a:rPr>
+              <a:t> </a:t>
+            </a:r>
+            <a:r>
+              <a:rPr sz="1400" b="1" dirty="0" err="1">
+                <a:solidFill>
+                  <a:srgbClr val="0F172A"/>
+                </a:solidFill>
+                <a:latin typeface="Pretendard"/>
+              </a:rPr>
+              <a:t>등록</a:t>
+            </a:r>
+            <a:r>
+              <a:rPr sz="1400" b="1" dirty="0">
+                <a:solidFill>
+                  <a:srgbClr val="0F172A"/>
+                </a:solidFill>
+                <a:latin typeface="Pretendard"/>
+              </a:rPr>
+              <a:t> → </a:t>
+            </a:r>
+            <a:r>
+              <a:rPr sz="1400" b="1" dirty="0" err="1">
+                <a:solidFill>
+                  <a:srgbClr val="0F172A"/>
+                </a:solidFill>
+                <a:latin typeface="Pretendard"/>
+              </a:rPr>
+              <a:t>출근완료로</a:t>
+            </a:r>
+            <a:r>
+              <a:rPr sz="1400" b="1" dirty="0">
+                <a:solidFill>
+                  <a:srgbClr val="0F172A"/>
+                </a:solidFill>
+                <a:latin typeface="Pretendard"/>
+              </a:rPr>
+              <a:t> </a:t>
+            </a:r>
+            <a:r>
+              <a:rPr sz="1400" b="1" dirty="0" err="1">
+                <a:solidFill>
+                  <a:srgbClr val="0F172A"/>
+                </a:solidFill>
+                <a:latin typeface="Pretendard"/>
+              </a:rPr>
+              <a:t>실제</a:t>
+            </a:r>
+            <a:r>
+              <a:rPr sz="1400" b="1" dirty="0">
+                <a:solidFill>
+                  <a:srgbClr val="0F172A"/>
+                </a:solidFill>
+                <a:latin typeface="Pretendard"/>
+              </a:rPr>
+              <a:t> </a:t>
+            </a:r>
+            <a:r>
+              <a:rPr sz="1400" b="1" dirty="0" err="1">
+                <a:solidFill>
+                  <a:srgbClr val="0F172A"/>
+                </a:solidFill>
+                <a:latin typeface="Pretendard"/>
+              </a:rPr>
+              <a:t>시각</a:t>
+            </a:r>
+            <a:r>
+              <a:rPr sz="1400" b="1" dirty="0">
+                <a:solidFill>
+                  <a:srgbClr val="0F172A"/>
+                </a:solidFill>
+                <a:latin typeface="Pretendard"/>
+              </a:rPr>
+              <a:t> </a:t>
+            </a:r>
+            <a:r>
+              <a:rPr sz="1400" b="1" dirty="0" err="1">
+                <a:solidFill>
+                  <a:srgbClr val="0F172A"/>
+                </a:solidFill>
+                <a:latin typeface="Pretendard"/>
+              </a:rPr>
+              <a:t>확정</a:t>
+            </a:r>
+            <a:endParaRPr sz="1400" b="1" dirty="0">
+              <a:solidFill>
+                <a:srgbClr val="0F172A"/>
+              </a:solidFill>
+              <a:latin typeface="Pretendard"/>
+            </a:endParaRPr>
           </a:p>
         </p:txBody>
       </p:sp>
@@ -16215,14 +16512,101 @@
               </a:lnSpc>
             </a:pPr>
             <a:r>
-              <a:rPr sz="1100" b="0">
+              <a:rPr sz="1100" b="0" dirty="0">
                 <a:solidFill>
                   <a:srgbClr val="64748B"/>
                 </a:solidFill>
                 <a:latin typeface="Pretendard"/>
               </a:rPr>
-              <a:t>두 단계 모두 30분 단위 수정 가능</a:t>
-            </a:r>
+              <a:t>두 </a:t>
+            </a:r>
+            <a:r>
+              <a:rPr sz="1100" b="0" dirty="0" err="1">
+                <a:solidFill>
+                  <a:srgbClr val="64748B"/>
+                </a:solidFill>
+                <a:latin typeface="Pretendard"/>
+              </a:rPr>
+              <a:t>단계</a:t>
+            </a:r>
+            <a:r>
+              <a:rPr sz="1100" b="0" dirty="0">
+                <a:solidFill>
+                  <a:srgbClr val="64748B"/>
+                </a:solidFill>
+                <a:latin typeface="Pretendard"/>
+              </a:rPr>
+              <a:t> </a:t>
+            </a:r>
+            <a:r>
+              <a:rPr sz="1100" b="0" dirty="0" err="1">
+                <a:solidFill>
+                  <a:srgbClr val="64748B"/>
+                </a:solidFill>
+                <a:latin typeface="Pretendard"/>
+              </a:rPr>
+              <a:t>모두</a:t>
+            </a:r>
+            <a:r>
+              <a:rPr sz="1100" b="0" dirty="0">
+                <a:solidFill>
+                  <a:srgbClr val="64748B"/>
+                </a:solidFill>
+                <a:latin typeface="Pretendard"/>
+              </a:rPr>
+              <a:t> 30분 </a:t>
+            </a:r>
+            <a:r>
+              <a:rPr sz="1100" b="0" dirty="0" err="1">
+                <a:solidFill>
+                  <a:srgbClr val="64748B"/>
+                </a:solidFill>
+                <a:latin typeface="Pretendard"/>
+              </a:rPr>
+              <a:t>단위</a:t>
+            </a:r>
+            <a:r>
+              <a:rPr sz="1100" b="0" dirty="0">
+                <a:solidFill>
+                  <a:srgbClr val="64748B"/>
+                </a:solidFill>
+                <a:latin typeface="Pretendard"/>
+              </a:rPr>
+              <a:t> </a:t>
+            </a:r>
+            <a:r>
+              <a:rPr sz="1100" b="0" dirty="0" err="1">
+                <a:solidFill>
+                  <a:srgbClr val="64748B"/>
+                </a:solidFill>
+                <a:latin typeface="Pretendard"/>
+              </a:rPr>
+              <a:t>수정</a:t>
+            </a:r>
+            <a:r>
+              <a:rPr sz="1100" b="0" dirty="0">
+                <a:solidFill>
+                  <a:srgbClr val="64748B"/>
+                </a:solidFill>
+                <a:latin typeface="Pretendard"/>
+              </a:rPr>
+              <a:t> </a:t>
+            </a:r>
+            <a:r>
+              <a:rPr sz="1100" b="0" dirty="0" err="1">
+                <a:solidFill>
+                  <a:srgbClr val="64748B"/>
+                </a:solidFill>
+                <a:latin typeface="Pretendard"/>
+              </a:rPr>
+              <a:t>가능</a:t>
+            </a:r>
+            <a:endParaRPr sz="1100" b="0" dirty="0">
+              <a:solidFill>
+                <a:srgbClr val="64748B"/>
+              </a:solidFill>
+              <a:latin typeface="Pretendard"/>
+            </a:endParaRPr>
           </a:p>
         </p:txBody>
       </p:sp>
@@ -16339,14 +16723,92 @@
               </a:lnSpc>
             </a:pPr>
             <a:r>
-              <a:rPr sz="1400" b="1">
+              <a:rPr sz="1400" b="1" dirty="0" err="1">
                 <a:solidFill>
                   <a:srgbClr val="0F172A"/>
                 </a:solidFill>
                 <a:latin typeface="Pretendard"/>
               </a:rPr>
-              <a:t>근무지 칩 — 사무실 / 재택 / 외근 / 기타</a:t>
-            </a:r>
+              <a:t>근무지</a:t>
+            </a:r>
+            <a:r>
+              <a:rPr sz="1400" b="1" dirty="0">
+                <a:solidFill>
+                  <a:srgbClr val="0F172A"/>
+                </a:solidFill>
+                <a:latin typeface="Pretendard"/>
+              </a:rPr>
+              <a:t> 칩 — </a:t>
+            </a:r>
+            <a:r>
+              <a:rPr sz="1400" b="1" dirty="0" err="1">
+                <a:solidFill>
+                  <a:srgbClr val="0F172A"/>
+                </a:solidFill>
+                <a:latin typeface="Pretendard"/>
+              </a:rPr>
+              <a:t>사무실</a:t>
+            </a:r>
+            <a:r>
+              <a:rPr sz="1400" b="1" dirty="0">
+                <a:solidFill>
+                  <a:srgbClr val="0F172A"/>
+                </a:solidFill>
+                <a:latin typeface="Pretendard"/>
+              </a:rPr>
+              <a:t> / </a:t>
+            </a:r>
+            <a:r>
+              <a:rPr sz="1400" b="1" dirty="0" err="1">
+                <a:solidFill>
+                  <a:srgbClr val="0F172A"/>
+                </a:solidFill>
+                <a:latin typeface="Pretendard"/>
+              </a:rPr>
+              <a:t>재택</a:t>
+            </a:r>
+            <a:r>
+              <a:rPr sz="1400" b="1" dirty="0">
+                <a:solidFill>
+                  <a:srgbClr val="0F172A"/>
+                </a:solidFill>
+                <a:latin typeface="Pretendard"/>
+              </a:rPr>
+              <a:t> / </a:t>
+            </a:r>
+            <a:r>
+              <a:rPr sz="1400" b="1" dirty="0" err="1">
+                <a:solidFill>
+                  <a:srgbClr val="0F172A"/>
+                </a:solidFill>
+                <a:latin typeface="Pretendard"/>
+              </a:rPr>
+              <a:t>외근</a:t>
+            </a:r>
+            <a:r>
+              <a:rPr sz="1400" b="1" dirty="0">
+                <a:solidFill>
+                  <a:srgbClr val="0F172A"/>
+                </a:solidFill>
+                <a:latin typeface="Pretendard"/>
+              </a:rPr>
+              <a:t> / </a:t>
+            </a:r>
+            <a:r>
+              <a:rPr sz="1400" b="1" dirty="0" err="1">
+                <a:solidFill>
+                  <a:srgbClr val="0F172A"/>
+                </a:solidFill>
+                <a:latin typeface="Pretendard"/>
+              </a:rPr>
+              <a:t>기타</a:t>
+            </a:r>
+            <a:endParaRPr sz="1400" b="1" dirty="0">
+              <a:solidFill>
+                <a:srgbClr val="0F172A"/>
+              </a:solidFill>
+              <a:latin typeface="Pretendard"/>
+            </a:endParaRPr>
           </a:p>
         </p:txBody>
       </p:sp>
@@ -16378,14 +16840,83 @@
               </a:lnSpc>
             </a:pPr>
             <a:r>
-              <a:rPr sz="1100" b="0">
+              <a:rPr sz="1100" b="0" dirty="0">
                 <a:solidFill>
                   <a:srgbClr val="64748B"/>
                 </a:solidFill>
                 <a:latin typeface="Pretendard"/>
               </a:rPr>
-              <a:t>한 줄 추가 + ★로 현재 위치 마커</a:t>
-            </a:r>
+              <a:t>한 줄 </a:t>
+            </a:r>
+            <a:r>
+              <a:rPr sz="1100" b="0" dirty="0" err="1">
+                <a:solidFill>
+                  <a:srgbClr val="64748B"/>
+                </a:solidFill>
+                <a:latin typeface="Pretendard"/>
+              </a:rPr>
+              <a:t>추가</a:t>
+            </a:r>
+            <a:r>
+              <a:rPr sz="1100" b="0" dirty="0">
+                <a:solidFill>
+                  <a:srgbClr val="64748B"/>
+                </a:solidFill>
+                <a:latin typeface="Pretendard"/>
+              </a:rPr>
+              <a:t> + ★로 </a:t>
+            </a:r>
+            <a:r>
+              <a:rPr sz="1100" b="0" dirty="0" err="1">
+                <a:solidFill>
+                  <a:srgbClr val="64748B"/>
+                </a:solidFill>
+                <a:latin typeface="Pretendard"/>
+              </a:rPr>
+              <a:t>현재</a:t>
+            </a:r>
+            <a:r>
+              <a:rPr sz="1100" b="0" dirty="0">
+                <a:solidFill>
+                  <a:srgbClr val="64748B"/>
+                </a:solidFill>
+                <a:latin typeface="Pretendard"/>
+              </a:rPr>
+              <a:t> </a:t>
+            </a:r>
+            <a:r>
+              <a:rPr sz="1100" b="0" dirty="0" err="1">
+                <a:solidFill>
+                  <a:srgbClr val="64748B"/>
+                </a:solidFill>
+                <a:latin typeface="Pretendard"/>
+              </a:rPr>
+              <a:t>위치</a:t>
+            </a:r>
+            <a:r>
+              <a:rPr sz="1100" b="0" dirty="0">
+                <a:solidFill>
+                  <a:srgbClr val="64748B"/>
+                </a:solidFill>
+                <a:latin typeface="Pretendard"/>
+              </a:rPr>
+              <a:t> </a:t>
+            </a:r>
+            <a:r>
+              <a:rPr sz="1100" b="0" dirty="0" err="1">
+                <a:solidFill>
+                  <a:srgbClr val="64748B"/>
+                </a:solidFill>
+                <a:latin typeface="Pretendard"/>
+              </a:rPr>
+              <a:t>마커</a:t>
+            </a:r>
+            <a:endParaRPr sz="1100" b="0" dirty="0">
+              <a:solidFill>
+                <a:srgbClr val="64748B"/>
+              </a:solidFill>
+              <a:latin typeface="Pretendard"/>
+            </a:endParaRPr>
           </a:p>
         </p:txBody>
       </p:sp>
@@ -16483,7 +17014,7 @@
         <p:spPr>
           <a:xfrm>
             <a:off x="1325880" y="4343400"/>
-            <a:ext cx="5120640" cy="365760"/>
+            <a:ext cx="5120640" cy="237437"/>
           </a:xfrm>
           <a:prstGeom prst="rect">
             <a:avLst/>
@@ -16502,14 +17033,20 @@
               </a:lnSpc>
             </a:pPr>
             <a:r>
-              <a:rPr sz="1400" b="1">
+              <a:rPr lang="ko-KR" altLang="en-US" sz="1400" b="1" dirty="0">
                 <a:solidFill>
                   <a:srgbClr val="0F172A"/>
                 </a:solidFill>
                 <a:latin typeface="Pretendard"/>
               </a:rPr>
-              <a:t>새벽 근무 후엔 어제 날짜로 이동해서 보고</a:t>
-            </a:r>
+              <a:t>매일 출근 보고 리마인드 알림 발송</a:t>
+            </a:r>
+            <a:endParaRPr sz="1400" b="1" dirty="0">
+              <a:solidFill>
+                <a:srgbClr val="0F172A"/>
+              </a:solidFill>
+              <a:latin typeface="Pretendard"/>
+            </a:endParaRPr>
           </a:p>
         </p:txBody>
       </p:sp>
@@ -16522,7 +17059,7 @@
         <p:spPr>
           <a:xfrm>
             <a:off x="1325880" y="4690872"/>
-            <a:ext cx="5120640" cy="365760"/>
+            <a:ext cx="5120640" cy="186590"/>
           </a:xfrm>
           <a:prstGeom prst="rect">
             <a:avLst/>
@@ -16541,14 +17078,29 @@
               </a:lnSpc>
             </a:pPr>
             <a:r>
-              <a:rPr sz="1100" b="0">
+              <a:rPr lang="ko-KR" altLang="en-US" sz="1100" b="0" dirty="0" err="1">
                 <a:solidFill>
                   <a:srgbClr val="64748B"/>
                 </a:solidFill>
                 <a:latin typeface="Pretendard"/>
               </a:rPr>
-              <a:t>MY PAGE 헤더의 날짜 chevron 사용</a:t>
-            </a:r>
+              <a:t>미보고</a:t>
+            </a:r>
+            <a:r>
+              <a:rPr lang="ko-KR" altLang="en-US" sz="1100" b="0" dirty="0">
+                <a:solidFill>
+                  <a:srgbClr val="64748B"/>
+                </a:solidFill>
+                <a:latin typeface="Pretendard"/>
+              </a:rPr>
+              <a:t> 시 알림 발송</a:t>
+            </a:r>
+            <a:endParaRPr sz="1100" b="0" dirty="0">
+              <a:solidFill>
+                <a:srgbClr val="64748B"/>
+              </a:solidFill>
+              <a:latin typeface="Pretendard"/>
+            </a:endParaRPr>
           </a:p>
         </p:txBody>
       </p:sp>
@@ -22270,8 +22822,8 @@
         </p:nvSpPr>
         <p:spPr>
           <a:xfrm>
-            <a:off x="868680" y="5943600"/>
-            <a:ext cx="10515600" cy="457200"/>
+            <a:off x="868680" y="6079129"/>
+            <a:ext cx="10515600" cy="186141"/>
           </a:xfrm>
           <a:prstGeom prst="rect">
             <a:avLst/>
@@ -22290,14 +22842,170 @@
               </a:lnSpc>
             </a:pPr>
             <a:r>
-              <a:rPr sz="1100" b="0">
+              <a:rPr sz="1100" b="0" dirty="0">
                 <a:solidFill>
                   <a:srgbClr val="1E40AF"/>
                 </a:solidFill>
                 <a:latin typeface="Pretendard"/>
               </a:rPr>
-              <a:t>💡  휴가/반차 등록 후 휴가상신 페이지로 자동 연결 — 별도 사이트 안 들어가도 됨</a:t>
-            </a:r>
+              <a:t>💡  </a:t>
+            </a:r>
+            <a:r>
+              <a:rPr sz="1100" b="0" dirty="0" err="1">
+                <a:solidFill>
+                  <a:srgbClr val="1E40AF"/>
+                </a:solidFill>
+                <a:latin typeface="Pretendard"/>
+              </a:rPr>
+              <a:t>휴가</a:t>
+            </a:r>
+            <a:r>
+              <a:rPr sz="1100" b="0" dirty="0">
+                <a:solidFill>
+                  <a:srgbClr val="1E40AF"/>
+                </a:solidFill>
+                <a:latin typeface="Pretendard"/>
+              </a:rPr>
+              <a:t>/</a:t>
+            </a:r>
+            <a:r>
+              <a:rPr sz="1100" b="0" dirty="0" err="1">
+                <a:solidFill>
+                  <a:srgbClr val="1E40AF"/>
+                </a:solidFill>
+                <a:latin typeface="Pretendard"/>
+              </a:rPr>
+              <a:t>반차</a:t>
+            </a:r>
+            <a:r>
+              <a:rPr sz="1100" b="0" dirty="0">
+                <a:solidFill>
+                  <a:srgbClr val="1E40AF"/>
+                </a:solidFill>
+                <a:latin typeface="Pretendard"/>
+              </a:rPr>
+              <a:t> </a:t>
+            </a:r>
+            <a:r>
+              <a:rPr sz="1100" b="0" dirty="0" err="1">
+                <a:solidFill>
+                  <a:srgbClr val="1E40AF"/>
+                </a:solidFill>
+                <a:latin typeface="Pretendard"/>
+              </a:rPr>
+              <a:t>등록</a:t>
+            </a:r>
+            <a:r>
+              <a:rPr sz="1100" b="0" dirty="0">
+                <a:solidFill>
+                  <a:srgbClr val="1E40AF"/>
+                </a:solidFill>
+                <a:latin typeface="Pretendard"/>
+              </a:rPr>
+              <a:t> 후 </a:t>
+            </a:r>
+            <a:r>
+              <a:rPr sz="1100" b="0" dirty="0" err="1">
+                <a:solidFill>
+                  <a:srgbClr val="1E40AF"/>
+                </a:solidFill>
+                <a:latin typeface="Pretendard"/>
+              </a:rPr>
+              <a:t>휴가상신</a:t>
+            </a:r>
+            <a:r>
+              <a:rPr sz="1100" b="0" dirty="0">
+                <a:solidFill>
+                  <a:srgbClr val="1E40AF"/>
+                </a:solidFill>
+                <a:latin typeface="Pretendard"/>
+              </a:rPr>
+              <a:t> </a:t>
+            </a:r>
+            <a:r>
+              <a:rPr sz="1100" b="0" dirty="0" err="1">
+                <a:solidFill>
+                  <a:srgbClr val="1E40AF"/>
+                </a:solidFill>
+                <a:latin typeface="Pretendard"/>
+              </a:rPr>
+              <a:t>페이지로</a:t>
+            </a:r>
+            <a:r>
+              <a:rPr sz="1100" b="0" dirty="0">
+                <a:solidFill>
+                  <a:srgbClr val="1E40AF"/>
+                </a:solidFill>
+                <a:latin typeface="Pretendard"/>
+              </a:rPr>
+              <a:t> </a:t>
+            </a:r>
+            <a:r>
+              <a:rPr sz="1100" b="0" dirty="0" err="1">
+                <a:solidFill>
+                  <a:srgbClr val="1E40AF"/>
+                </a:solidFill>
+                <a:latin typeface="Pretendard"/>
+              </a:rPr>
+              <a:t>자동</a:t>
+            </a:r>
+            <a:r>
+              <a:rPr sz="1100" b="0" dirty="0">
+                <a:solidFill>
+                  <a:srgbClr val="1E40AF"/>
+                </a:solidFill>
+                <a:latin typeface="Pretendard"/>
+              </a:rPr>
+              <a:t> </a:t>
+            </a:r>
+            <a:r>
+              <a:rPr sz="1100" b="0" dirty="0" err="1">
+                <a:solidFill>
+                  <a:srgbClr val="1E40AF"/>
+                </a:solidFill>
+                <a:latin typeface="Pretendard"/>
+              </a:rPr>
+              <a:t>연결</a:t>
+            </a:r>
+            <a:r>
+              <a:rPr sz="1100" b="0" dirty="0">
+                <a:solidFill>
+                  <a:srgbClr val="1E40AF"/>
+                </a:solidFill>
+                <a:latin typeface="Pretendard"/>
+              </a:rPr>
+              <a:t> — </a:t>
+            </a:r>
+            <a:r>
+              <a:rPr lang="ko-KR" altLang="en-US" sz="1100" b="0" dirty="0">
+                <a:solidFill>
+                  <a:srgbClr val="1E40AF"/>
+                </a:solidFill>
+                <a:latin typeface="Pretendard Light" panose="02000403000000020004" pitchFamily="50" charset="-127"/>
+                <a:ea typeface="Pretendard Light" panose="02000403000000020004" pitchFamily="50" charset="-127"/>
+                <a:cs typeface="Pretendard Light" panose="02000403000000020004" pitchFamily="50" charset="-127"/>
+              </a:rPr>
+              <a:t>이동 </a:t>
+            </a:r>
+            <a:r>
+              <a:rPr lang="ko-KR" altLang="en-US" sz="1100" dirty="0">
+                <a:solidFill>
+                  <a:srgbClr val="1E40AF"/>
+                </a:solidFill>
+                <a:latin typeface="Pretendard Light" panose="02000403000000020004" pitchFamily="50" charset="-127"/>
+                <a:ea typeface="Pretendard Light" panose="02000403000000020004" pitchFamily="50" charset="-127"/>
+                <a:cs typeface="Pretendard Light" panose="02000403000000020004" pitchFamily="50" charset="-127"/>
+              </a:rPr>
+              <a:t>시간 단축</a:t>
+            </a:r>
+            <a:endParaRPr sz="1100" b="0" dirty="0">
+              <a:solidFill>
+                <a:srgbClr val="1E40AF"/>
+              </a:solidFill>
+              <a:latin typeface="Pretendard Light" panose="02000403000000020004" pitchFamily="50" charset="-127"/>
+              <a:ea typeface="Pretendard Light" panose="02000403000000020004" pitchFamily="50" charset="-127"/>
+              <a:cs typeface="Pretendard Light" panose="02000403000000020004" pitchFamily="50" charset="-127"/>
+            </a:endParaRPr>
           </a:p>
         </p:txBody>
       </p:sp>

</xml_diff>

<commit_message>
feat(work-log): 5-tier work type with Sun/holiday lockout + EW preview warning
</commit_message>
<xml_diff>
--- a/N-Click_가이드.pptx
+++ b/N-Click_가이드.pptx
@@ -312,7 +312,7 @@
           <a:p>
             <a:fld id="{5BCAD085-E8A6-8845-BD4E-CB4CCA059FC4}" type="datetimeFigureOut">
               <a:rPr lang="en-US" smtClean="0"/>
-              <a:t>5/11/2026</a:t>
+              <a:t>5/7/2026</a:t>
             </a:fld>
             <a:endParaRPr lang="en-US"/>
           </a:p>
@@ -480,7 +480,7 @@
           <a:p>
             <a:fld id="{5BCAD085-E8A6-8845-BD4E-CB4CCA059FC4}" type="datetimeFigureOut">
               <a:rPr lang="en-US" smtClean="0"/>
-              <a:t>5/11/2026</a:t>
+              <a:t>5/7/2026</a:t>
             </a:fld>
             <a:endParaRPr lang="en-US"/>
           </a:p>
@@ -658,7 +658,7 @@
           <a:p>
             <a:fld id="{5BCAD085-E8A6-8845-BD4E-CB4CCA059FC4}" type="datetimeFigureOut">
               <a:rPr lang="en-US" smtClean="0"/>
-              <a:t>5/11/2026</a:t>
+              <a:t>5/7/2026</a:t>
             </a:fld>
             <a:endParaRPr lang="en-US"/>
           </a:p>
@@ -826,7 +826,7 @@
           <a:p>
             <a:fld id="{5BCAD085-E8A6-8845-BD4E-CB4CCA059FC4}" type="datetimeFigureOut">
               <a:rPr lang="en-US" smtClean="0"/>
-              <a:t>5/11/2026</a:t>
+              <a:t>5/7/2026</a:t>
             </a:fld>
             <a:endParaRPr lang="en-US"/>
           </a:p>
@@ -1071,7 +1071,7 @@
           <a:p>
             <a:fld id="{5BCAD085-E8A6-8845-BD4E-CB4CCA059FC4}" type="datetimeFigureOut">
               <a:rPr lang="en-US" smtClean="0"/>
-              <a:t>5/11/2026</a:t>
+              <a:t>5/7/2026</a:t>
             </a:fld>
             <a:endParaRPr lang="en-US"/>
           </a:p>
@@ -1356,7 +1356,7 @@
           <a:p>
             <a:fld id="{5BCAD085-E8A6-8845-BD4E-CB4CCA059FC4}" type="datetimeFigureOut">
               <a:rPr lang="en-US" smtClean="0"/>
-              <a:t>5/11/2026</a:t>
+              <a:t>5/7/2026</a:t>
             </a:fld>
             <a:endParaRPr lang="en-US"/>
           </a:p>
@@ -1775,7 +1775,7 @@
           <a:p>
             <a:fld id="{5BCAD085-E8A6-8845-BD4E-CB4CCA059FC4}" type="datetimeFigureOut">
               <a:rPr lang="en-US" smtClean="0"/>
-              <a:t>5/11/2026</a:t>
+              <a:t>5/7/2026</a:t>
             </a:fld>
             <a:endParaRPr lang="en-US"/>
           </a:p>
@@ -1892,7 +1892,7 @@
           <a:p>
             <a:fld id="{5BCAD085-E8A6-8845-BD4E-CB4CCA059FC4}" type="datetimeFigureOut">
               <a:rPr lang="en-US" smtClean="0"/>
-              <a:t>5/11/2026</a:t>
+              <a:t>5/7/2026</a:t>
             </a:fld>
             <a:endParaRPr lang="en-US"/>
           </a:p>
@@ -1987,7 +1987,7 @@
           <a:p>
             <a:fld id="{5BCAD085-E8A6-8845-BD4E-CB4CCA059FC4}" type="datetimeFigureOut">
               <a:rPr lang="en-US" smtClean="0"/>
-              <a:t>5/11/2026</a:t>
+              <a:t>5/7/2026</a:t>
             </a:fld>
             <a:endParaRPr lang="en-US"/>
           </a:p>
@@ -2262,7 +2262,7 @@
           <a:p>
             <a:fld id="{5BCAD085-E8A6-8845-BD4E-CB4CCA059FC4}" type="datetimeFigureOut">
               <a:rPr lang="en-US" smtClean="0"/>
-              <a:t>5/11/2026</a:t>
+              <a:t>5/7/2026</a:t>
             </a:fld>
             <a:endParaRPr lang="en-US"/>
           </a:p>
@@ -2514,7 +2514,7 @@
           <a:p>
             <a:fld id="{5BCAD085-E8A6-8845-BD4E-CB4CCA059FC4}" type="datetimeFigureOut">
               <a:rPr lang="en-US" smtClean="0"/>
-              <a:t>5/11/2026</a:t>
+              <a:t>5/7/2026</a:t>
             </a:fld>
             <a:endParaRPr lang="en-US"/>
           </a:p>
@@ -2725,7 +2725,7 @@
           <a:p>
             <a:fld id="{5BCAD085-E8A6-8845-BD4E-CB4CCA059FC4}" type="datetimeFigureOut">
               <a:rPr lang="en-US" smtClean="0"/>
-              <a:t>5/11/2026</a:t>
+              <a:t>5/7/2026</a:t>
             </a:fld>
             <a:endParaRPr lang="en-US"/>
           </a:p>
@@ -7802,7 +7802,7 @@
         <p:spPr>
           <a:xfrm>
             <a:off x="914400" y="3200400"/>
-            <a:ext cx="4910328" cy="224677"/>
+            <a:ext cx="4910328" cy="868680"/>
           </a:xfrm>
           <a:prstGeom prst="rect">
             <a:avLst/>
@@ -7821,175 +7821,13 @@
               </a:lnSpc>
             </a:pPr>
             <a:r>
-              <a:rPr sz="1100" b="0" dirty="0">
+              <a:rPr sz="1100" b="0">
                 <a:solidFill>
                   <a:srgbClr val="64748B"/>
                 </a:solidFill>
                 <a:latin typeface="Pretendard"/>
               </a:rPr>
-              <a:t>MY PAGE </a:t>
-            </a:r>
-            <a:r>
-              <a:rPr sz="1100" b="0" dirty="0" err="1">
-                <a:solidFill>
-                  <a:srgbClr val="64748B"/>
-                </a:solidFill>
-                <a:latin typeface="Pretendard"/>
-              </a:rPr>
-              <a:t>헤더의</a:t>
-            </a:r>
-            <a:r>
-              <a:rPr sz="1100" b="0" dirty="0">
-                <a:solidFill>
-                  <a:srgbClr val="64748B"/>
-                </a:solidFill>
-                <a:latin typeface="Pretendard"/>
-              </a:rPr>
-              <a:t> </a:t>
-            </a:r>
-            <a:r>
-              <a:rPr sz="1100" b="0" dirty="0" err="1">
-                <a:solidFill>
-                  <a:srgbClr val="64748B"/>
-                </a:solidFill>
-                <a:latin typeface="Pretendard"/>
-              </a:rPr>
-              <a:t>날짜</a:t>
-            </a:r>
-            <a:r>
-              <a:rPr sz="1100" b="0" dirty="0">
-                <a:solidFill>
-                  <a:srgbClr val="64748B"/>
-                </a:solidFill>
-                <a:latin typeface="Pretendard"/>
-              </a:rPr>
-              <a:t> </a:t>
-            </a:r>
-            <a:r>
-              <a:rPr sz="1100" b="0" err="1">
-                <a:solidFill>
-                  <a:srgbClr val="64748B"/>
-                </a:solidFill>
-                <a:latin typeface="Pretendard"/>
-              </a:rPr>
-              <a:t>좌측</a:t>
-            </a:r>
-            <a:r>
-              <a:rPr sz="1100" b="0">
-                <a:solidFill>
-                  <a:srgbClr val="64748B"/>
-                </a:solidFill>
-                <a:latin typeface="Pretendard"/>
-              </a:rPr>
-              <a:t> </a:t>
-            </a:r>
-            <a:r>
-              <a:rPr lang="ko-KR" altLang="en-US" sz="1100">
-                <a:solidFill>
-                  <a:srgbClr val="64748B"/>
-                </a:solidFill>
-                <a:latin typeface="Pretendard"/>
-              </a:rPr>
-              <a:t>버튼</a:t>
-            </a:r>
-            <a:r>
-              <a:rPr sz="1100" b="0">
-                <a:solidFill>
-                  <a:srgbClr val="64748B"/>
-                </a:solidFill>
-                <a:latin typeface="Pretendard"/>
-              </a:rPr>
-              <a:t>으로 </a:t>
-            </a:r>
-            <a:r>
-              <a:rPr sz="1100" b="0" dirty="0" err="1">
-                <a:solidFill>
-                  <a:srgbClr val="64748B"/>
-                </a:solidFill>
-                <a:latin typeface="Pretendard"/>
-              </a:rPr>
-              <a:t>어제</a:t>
-            </a:r>
-            <a:r>
-              <a:rPr sz="1100" b="0" dirty="0">
-                <a:solidFill>
-                  <a:srgbClr val="64748B"/>
-                </a:solidFill>
-                <a:latin typeface="Pretendard"/>
-              </a:rPr>
-              <a:t> </a:t>
-            </a:r>
-            <a:r>
-              <a:rPr sz="1100" b="0" dirty="0" err="1">
-                <a:solidFill>
-                  <a:srgbClr val="64748B"/>
-                </a:solidFill>
-                <a:latin typeface="Pretendard"/>
-              </a:rPr>
-              <a:t>날짜로</a:t>
-            </a:r>
-            <a:r>
-              <a:rPr sz="1100" b="0" dirty="0">
-                <a:solidFill>
-                  <a:srgbClr val="64748B"/>
-                </a:solidFill>
-                <a:latin typeface="Pretendard"/>
-              </a:rPr>
-              <a:t> </a:t>
-            </a:r>
-            <a:r>
-              <a:rPr sz="1100" b="0" dirty="0" err="1">
-                <a:solidFill>
-                  <a:srgbClr val="64748B"/>
-                </a:solidFill>
-                <a:latin typeface="Pretendard"/>
-              </a:rPr>
-              <a:t>이동</a:t>
-            </a:r>
-            <a:r>
-              <a:rPr sz="1100" b="0" dirty="0">
-                <a:solidFill>
-                  <a:srgbClr val="64748B"/>
-                </a:solidFill>
-                <a:latin typeface="Pretendard"/>
-              </a:rPr>
-              <a:t> → </a:t>
-            </a:r>
-            <a:r>
-              <a:rPr sz="1100" b="0" dirty="0" err="1">
-                <a:solidFill>
-                  <a:srgbClr val="64748B"/>
-                </a:solidFill>
-                <a:latin typeface="Pretendard"/>
-              </a:rPr>
-              <a:t>평소처럼</a:t>
-            </a:r>
-            <a:r>
-              <a:rPr sz="1100" b="0" dirty="0">
-                <a:solidFill>
-                  <a:srgbClr val="64748B"/>
-                </a:solidFill>
-                <a:latin typeface="Pretendard"/>
-              </a:rPr>
-              <a:t> </a:t>
-            </a:r>
-            <a:r>
-              <a:rPr sz="1100" b="0" dirty="0" err="1">
-                <a:solidFill>
-                  <a:srgbClr val="64748B"/>
-                </a:solidFill>
-                <a:latin typeface="Pretendard"/>
-              </a:rPr>
-              <a:t>보고</a:t>
-            </a:r>
-            <a:r>
-              <a:rPr sz="1100" b="0" dirty="0">
-                <a:solidFill>
-                  <a:srgbClr val="64748B"/>
-                </a:solidFill>
-                <a:latin typeface="Pretendard"/>
-              </a:rPr>
-              <a:t>.</a:t>
+              <a:t>MY PAGE 헤더의 날짜 좌측 chevron(&lt;)으로 어제 날짜로 이동 → 평소처럼 보고.</a:t>
             </a:r>
           </a:p>
         </p:txBody>
@@ -9233,7 +9071,7 @@
                 <a:ea typeface="Pretendard" panose="02000503000000020004" pitchFamily="50" charset="-127"/>
                 <a:cs typeface="Pretendard" panose="02000503000000020004" pitchFamily="50" charset="-127"/>
               </a:rPr>
-              <a:t> 시 </a:t>
+              <a:t xml:space="preserve"> 시 </a:t>
             </a:r>
             <a:r>
               <a:rPr sz="1200" dirty="0" err="1">
@@ -9255,7 +9093,7 @@
                 <a:ea typeface="Pretendard" panose="02000503000000020004" pitchFamily="50" charset="-127"/>
                 <a:cs typeface="Pretendard" panose="02000503000000020004" pitchFamily="50" charset="-127"/>
               </a:rPr>
-              <a:t> </a:t>
+              <a:t xml:space="preserve"> </a:t>
             </a:r>
             <a:r>
               <a:rPr sz="1200" dirty="0" err="1">
@@ -9277,7 +9115,7 @@
                 <a:ea typeface="Pretendard" panose="02000503000000020004" pitchFamily="50" charset="-127"/>
                 <a:cs typeface="Pretendard" panose="02000503000000020004" pitchFamily="50" charset="-127"/>
               </a:rPr>
-              <a:t> 09시로 </a:t>
+              <a:t xml:space="preserve"> 09시로 </a:t>
             </a:r>
             <a:r>
               <a:rPr sz="1200" dirty="0" err="1">
@@ -9299,7 +9137,7 @@
                 <a:ea typeface="Pretendard" panose="02000503000000020004" pitchFamily="50" charset="-127"/>
                 <a:cs typeface="Pretendard" panose="02000503000000020004" pitchFamily="50" charset="-127"/>
               </a:rPr>
-              <a:t> </a:t>
+              <a:t xml:space="preserve"> </a:t>
             </a:r>
             <a:r>
               <a:rPr sz="1200" dirty="0" err="1">
@@ -9321,7 +9159,7 @@
                 <a:ea typeface="Pretendard" panose="02000503000000020004" pitchFamily="50" charset="-127"/>
                 <a:cs typeface="Pretendard" panose="02000503000000020004" pitchFamily="50" charset="-127"/>
               </a:rPr>
-              <a:t> </a:t>
+              <a:t xml:space="preserve"> </a:t>
             </a:r>
             <a:r>
               <a:rPr sz="1200" dirty="0" err="1">
@@ -9343,7 +9181,7 @@
                 <a:ea typeface="Pretendard" panose="02000503000000020004" pitchFamily="50" charset="-127"/>
                 <a:cs typeface="Pretendard" panose="02000503000000020004" pitchFamily="50" charset="-127"/>
               </a:rPr>
-              <a:t> </a:t>
+              <a:t xml:space="preserve"> </a:t>
             </a:r>
             <a:r>
               <a:rPr sz="1200" dirty="0" err="1">
@@ -9376,7 +9214,7 @@
                 <a:ea typeface="Pretendard" panose="02000503000000020004" pitchFamily="50" charset="-127"/>
                 <a:cs typeface="Pretendard" panose="02000503000000020004" pitchFamily="50" charset="-127"/>
               </a:rPr>
-              <a:t>, </a:t>
+              <a:t xml:space="preserve">, </a:t>
             </a:r>
             <a:r>
               <a:rPr sz="1200" dirty="0" err="1">
@@ -9398,7 +9236,7 @@
                 <a:ea typeface="Pretendard" panose="02000503000000020004" pitchFamily="50" charset="-127"/>
                 <a:cs typeface="Pretendard" panose="02000503000000020004" pitchFamily="50" charset="-127"/>
               </a:rPr>
-              <a:t> </a:t>
+              <a:t xml:space="preserve"> </a:t>
             </a:r>
             <a:r>
               <a:rPr sz="1200" dirty="0" err="1">
@@ -9420,7 +9258,7 @@
                 <a:ea typeface="Pretendard" panose="02000503000000020004" pitchFamily="50" charset="-127"/>
                 <a:cs typeface="Pretendard" panose="02000503000000020004" pitchFamily="50" charset="-127"/>
               </a:rPr>
-              <a:t> </a:t>
+              <a:t xml:space="preserve"> </a:t>
             </a:r>
             <a:r>
               <a:rPr sz="1200" dirty="0" err="1">
@@ -9442,7 +9280,7 @@
                 <a:ea typeface="Pretendard" panose="02000503000000020004" pitchFamily="50" charset="-127"/>
                 <a:cs typeface="Pretendard" panose="02000503000000020004" pitchFamily="50" charset="-127"/>
               </a:rPr>
-              <a:t> </a:t>
+              <a:t xml:space="preserve"> </a:t>
             </a:r>
             <a:r>
               <a:rPr sz="1200" dirty="0" err="1">
@@ -9682,7 +9520,7 @@
                 </a:solidFill>
                 <a:latin typeface="Pretendard"/>
               </a:rPr>
-              <a:t> </a:t>
+              <a:t xml:space="preserve"> </a:t>
             </a:r>
             <a:r>
               <a:rPr sz="1200" b="0" dirty="0" err="1">
@@ -9700,7 +9538,7 @@
                 </a:solidFill>
                 <a:latin typeface="Pretendard"/>
               </a:rPr>
-              <a:t> </a:t>
+              <a:t xml:space="preserve"> </a:t>
             </a:r>
             <a:r>
               <a:rPr sz="1200" b="0" dirty="0" err="1">
@@ -9718,7 +9556,7 @@
                 </a:solidFill>
                 <a:latin typeface="Pretendard"/>
               </a:rPr>
-              <a:t> </a:t>
+              <a:t xml:space="preserve"> </a:t>
             </a:r>
             <a:r>
               <a:rPr sz="1200" b="0" dirty="0" err="1">
@@ -9736,7 +9574,7 @@
                 </a:solidFill>
                 <a:latin typeface="Pretendard"/>
               </a:rPr>
-              <a:t>, </a:t>
+              <a:t xml:space="preserve">, </a:t>
             </a:r>
             <a:r>
               <a:rPr sz="1200" b="0" dirty="0" err="1">
@@ -9772,7 +9610,7 @@
                 </a:solidFill>
                 <a:latin typeface="Pretendard"/>
               </a:rPr>
-              <a:t> </a:t>
+              <a:t xml:space="preserve"> </a:t>
             </a:r>
             <a:r>
               <a:rPr sz="1200" b="0" dirty="0" err="1">
@@ -9790,7 +9628,7 @@
                 </a:solidFill>
                 <a:latin typeface="Pretendard"/>
               </a:rPr>
-              <a:t> </a:t>
+              <a:t xml:space="preserve"> </a:t>
             </a:r>
             <a:r>
               <a:rPr sz="1200" b="0" dirty="0" err="1">
@@ -9808,7 +9646,7 @@
                 </a:solidFill>
                 <a:latin typeface="Pretendard"/>
               </a:rPr>
-              <a:t> </a:t>
+              <a:t xml:space="preserve"> </a:t>
             </a:r>
             <a:r>
               <a:rPr sz="1200" b="0" dirty="0" err="1">
@@ -9826,7 +9664,7 @@
                 </a:solidFill>
                 <a:latin typeface="Pretendard"/>
               </a:rPr>
-              <a:t> </a:t>
+              <a:t xml:space="preserve"> </a:t>
             </a:r>
             <a:r>
               <a:rPr sz="1200" b="0" dirty="0" err="1">
@@ -9844,7 +9682,7 @@
                 </a:solidFill>
                 <a:latin typeface="Pretendard"/>
               </a:rPr>
-              <a:t> </a:t>
+              <a:t xml:space="preserve"> </a:t>
             </a:r>
             <a:r>
               <a:rPr sz="1200" b="0" dirty="0" err="1">
@@ -9862,7 +9700,7 @@
                 </a:solidFill>
                 <a:latin typeface="Pretendard"/>
               </a:rPr>
-              <a:t> </a:t>
+              <a:t xml:space="preserve"> </a:t>
             </a:r>
             <a:r>
               <a:rPr sz="1200" b="0" dirty="0" err="1">
@@ -9880,7 +9718,7 @@
                 </a:solidFill>
                 <a:latin typeface="Pretendard"/>
               </a:rPr>
-              <a:t> </a:t>
+              <a:t xml:space="preserve"> </a:t>
             </a:r>
             <a:r>
               <a:rPr sz="1200" b="0" dirty="0" err="1">
@@ -13263,7 +13101,7 @@
                 </a:solidFill>
                 <a:latin typeface="Pretendard"/>
               </a:rPr>
-              <a:t>팀원 모두의 출퇴근 상태를 한 화면에서 확인</a:t>
+              <a:t>팀원 출퇴근 + 본부 캘린더 일정/휴가까지 한 화면 (1시간마다 자동 동기화)</a:t>
             </a:r>
           </a:p>
         </p:txBody>
@@ -14073,8 +13911,8 @@
         </p:nvSpPr>
         <p:spPr>
           <a:xfrm>
-            <a:off x="1234440" y="4724945"/>
-            <a:ext cx="2011680" cy="169598"/>
+            <a:off x="1234440" y="4663440"/>
+            <a:ext cx="2011680" cy="292608"/>
           </a:xfrm>
           <a:prstGeom prst="rect">
             <a:avLst/>
@@ -14093,29 +13931,14 @@
               </a:lnSpc>
             </a:pPr>
             <a:r>
-              <a:rPr sz="1000" b="1" dirty="0" err="1">
+              <a:rPr sz="1000" b="1">
                 <a:solidFill>
                   <a:srgbClr val="2563EB"/>
                 </a:solidFill>
                 <a:latin typeface="Pretendard"/>
               </a:rPr>
-              <a:t>출근</a:t>
-            </a:r>
-            <a:r>
-              <a:rPr lang="ko-KR" altLang="en-US" sz="1000" b="1" dirty="0">
-                <a:solidFill>
-                  <a:srgbClr val="2563EB"/>
-                </a:solidFill>
-                <a:latin typeface="Pretendard"/>
-              </a:rPr>
-              <a:t>보고 완료</a:t>
-            </a:r>
-            <a:endParaRPr sz="1000" b="1" dirty="0">
-              <a:solidFill>
-                <a:srgbClr val="2563EB"/>
-              </a:solidFill>
-              <a:latin typeface="Pretendard"/>
-            </a:endParaRPr>
+              <a:t>출근완료 대기</a:t>
+            </a:r>
           </a:p>
         </p:txBody>
       </p:sp>
@@ -16112,7 +15935,7 @@
               </a:lnSpc>
             </a:pPr>
             <a:r>
-              <a:rPr sz="3400" b="1" dirty="0" err="1">
+              <a:rPr sz="3400" b="1">
                 <a:solidFill>
                   <a:srgbClr val="0F172A"/>
                 </a:solidFill>
@@ -16120,12 +15943,6 @@
               </a:rPr>
               <a:t>출근하기</a:t>
             </a:r>
-            <a:endParaRPr sz="3400" b="1" dirty="0">
-              <a:solidFill>
-                <a:srgbClr val="0F172A"/>
-              </a:solidFill>
-              <a:latin typeface="Pretendard"/>
-            </a:endParaRPr>
           </a:p>
         </p:txBody>
       </p:sp>
@@ -16359,128 +16176,14 @@
               </a:lnSpc>
             </a:pPr>
             <a:r>
-              <a:rPr sz="1400" b="1" dirty="0" err="1">
+              <a:rPr sz="1400" b="1">
                 <a:solidFill>
                   <a:srgbClr val="0F172A"/>
                 </a:solidFill>
                 <a:latin typeface="Pretendard"/>
               </a:rPr>
-              <a:t>출근보고로</a:t>
-            </a:r>
-            <a:r>
-              <a:rPr sz="1400" b="1" dirty="0">
-                <a:solidFill>
-                  <a:srgbClr val="0F172A"/>
-                </a:solidFill>
-                <a:latin typeface="Pretendard"/>
-              </a:rPr>
-              <a:t> </a:t>
-            </a:r>
-            <a:r>
-              <a:rPr sz="1400" b="1" dirty="0" err="1">
-                <a:solidFill>
-                  <a:srgbClr val="0F172A"/>
-                </a:solidFill>
-                <a:latin typeface="Pretendard"/>
-              </a:rPr>
-              <a:t>예정</a:t>
-            </a:r>
-            <a:r>
-              <a:rPr sz="1400" b="1" dirty="0">
-                <a:solidFill>
-                  <a:srgbClr val="0F172A"/>
-                </a:solidFill>
-                <a:latin typeface="Pretendard"/>
-              </a:rPr>
-              <a:t> </a:t>
-            </a:r>
-            <a:r>
-              <a:rPr sz="1400" b="1" dirty="0" err="1">
-                <a:solidFill>
-                  <a:srgbClr val="0F172A"/>
-                </a:solidFill>
-                <a:latin typeface="Pretendard"/>
-              </a:rPr>
-              <a:t>등록</a:t>
-            </a:r>
-            <a:r>
-              <a:rPr sz="1400" b="1" dirty="0">
-                <a:solidFill>
-                  <a:srgbClr val="0F172A"/>
-                </a:solidFill>
-                <a:latin typeface="Pretendard"/>
-              </a:rPr>
-              <a:t> → </a:t>
-            </a:r>
-            <a:r>
-              <a:rPr sz="1400" b="1" dirty="0" err="1">
-                <a:solidFill>
-                  <a:srgbClr val="0F172A"/>
-                </a:solidFill>
-                <a:latin typeface="Pretendard"/>
-              </a:rPr>
-              <a:t>출근완료로</a:t>
-            </a:r>
-            <a:r>
-              <a:rPr sz="1400" b="1" dirty="0">
-                <a:solidFill>
-                  <a:srgbClr val="0F172A"/>
-                </a:solidFill>
-                <a:latin typeface="Pretendard"/>
-              </a:rPr>
-              <a:t> </a:t>
-            </a:r>
-            <a:r>
-              <a:rPr sz="1400" b="1" dirty="0" err="1">
-                <a:solidFill>
-                  <a:srgbClr val="0F172A"/>
-                </a:solidFill>
-                <a:latin typeface="Pretendard"/>
-              </a:rPr>
-              <a:t>실제</a:t>
-            </a:r>
-            <a:r>
-              <a:rPr sz="1400" b="1" dirty="0">
-                <a:solidFill>
-                  <a:srgbClr val="0F172A"/>
-                </a:solidFill>
-                <a:latin typeface="Pretendard"/>
-              </a:rPr>
-              <a:t> </a:t>
-            </a:r>
-            <a:r>
-              <a:rPr sz="1400" b="1" dirty="0" err="1">
-                <a:solidFill>
-                  <a:srgbClr val="0F172A"/>
-                </a:solidFill>
-                <a:latin typeface="Pretendard"/>
-              </a:rPr>
-              <a:t>시각</a:t>
-            </a:r>
-            <a:r>
-              <a:rPr sz="1400" b="1" dirty="0">
-                <a:solidFill>
-                  <a:srgbClr val="0F172A"/>
-                </a:solidFill>
-                <a:latin typeface="Pretendard"/>
-              </a:rPr>
-              <a:t> </a:t>
-            </a:r>
-            <a:r>
-              <a:rPr sz="1400" b="1" dirty="0" err="1">
-                <a:solidFill>
-                  <a:srgbClr val="0F172A"/>
-                </a:solidFill>
-                <a:latin typeface="Pretendard"/>
-              </a:rPr>
-              <a:t>확정</a:t>
-            </a:r>
-            <a:endParaRPr sz="1400" b="1" dirty="0">
-              <a:solidFill>
-                <a:srgbClr val="0F172A"/>
-              </a:solidFill>
-              <a:latin typeface="Pretendard"/>
-            </a:endParaRPr>
+              <a:t>출근보고로 예정 등록 → 출근완료로 실제 시각 확정</a:t>
+            </a:r>
           </a:p>
         </p:txBody>
       </p:sp>
@@ -16512,101 +16215,14 @@
               </a:lnSpc>
             </a:pPr>
             <a:r>
-              <a:rPr sz="1100" b="0" dirty="0">
+              <a:rPr sz="1100" b="0">
                 <a:solidFill>
                   <a:srgbClr val="64748B"/>
                 </a:solidFill>
                 <a:latin typeface="Pretendard"/>
               </a:rPr>
-              <a:t>두 </a:t>
-            </a:r>
-            <a:r>
-              <a:rPr sz="1100" b="0" dirty="0" err="1">
-                <a:solidFill>
-                  <a:srgbClr val="64748B"/>
-                </a:solidFill>
-                <a:latin typeface="Pretendard"/>
-              </a:rPr>
-              <a:t>단계</a:t>
-            </a:r>
-            <a:r>
-              <a:rPr sz="1100" b="0" dirty="0">
-                <a:solidFill>
-                  <a:srgbClr val="64748B"/>
-                </a:solidFill>
-                <a:latin typeface="Pretendard"/>
-              </a:rPr>
-              <a:t> </a:t>
-            </a:r>
-            <a:r>
-              <a:rPr sz="1100" b="0" dirty="0" err="1">
-                <a:solidFill>
-                  <a:srgbClr val="64748B"/>
-                </a:solidFill>
-                <a:latin typeface="Pretendard"/>
-              </a:rPr>
-              <a:t>모두</a:t>
-            </a:r>
-            <a:r>
-              <a:rPr sz="1100" b="0" dirty="0">
-                <a:solidFill>
-                  <a:srgbClr val="64748B"/>
-                </a:solidFill>
-                <a:latin typeface="Pretendard"/>
-              </a:rPr>
-              <a:t> 30분 </a:t>
-            </a:r>
-            <a:r>
-              <a:rPr sz="1100" b="0" dirty="0" err="1">
-                <a:solidFill>
-                  <a:srgbClr val="64748B"/>
-                </a:solidFill>
-                <a:latin typeface="Pretendard"/>
-              </a:rPr>
-              <a:t>단위</a:t>
-            </a:r>
-            <a:r>
-              <a:rPr sz="1100" b="0" dirty="0">
-                <a:solidFill>
-                  <a:srgbClr val="64748B"/>
-                </a:solidFill>
-                <a:latin typeface="Pretendard"/>
-              </a:rPr>
-              <a:t> </a:t>
-            </a:r>
-            <a:r>
-              <a:rPr sz="1100" b="0" dirty="0" err="1">
-                <a:solidFill>
-                  <a:srgbClr val="64748B"/>
-                </a:solidFill>
-                <a:latin typeface="Pretendard"/>
-              </a:rPr>
-              <a:t>수정</a:t>
-            </a:r>
-            <a:r>
-              <a:rPr sz="1100" b="0" dirty="0">
-                <a:solidFill>
-                  <a:srgbClr val="64748B"/>
-                </a:solidFill>
-                <a:latin typeface="Pretendard"/>
-              </a:rPr>
-              <a:t> </a:t>
-            </a:r>
-            <a:r>
-              <a:rPr sz="1100" b="0" dirty="0" err="1">
-                <a:solidFill>
-                  <a:srgbClr val="64748B"/>
-                </a:solidFill>
-                <a:latin typeface="Pretendard"/>
-              </a:rPr>
-              <a:t>가능</a:t>
-            </a:r>
-            <a:endParaRPr sz="1100" b="0" dirty="0">
-              <a:solidFill>
-                <a:srgbClr val="64748B"/>
-              </a:solidFill>
-              <a:latin typeface="Pretendard"/>
-            </a:endParaRPr>
+              <a:t>두 단계 모두 30분 단위 수정 가능</a:t>
+            </a:r>
           </a:p>
         </p:txBody>
       </p:sp>
@@ -16723,92 +16339,14 @@
               </a:lnSpc>
             </a:pPr>
             <a:r>
-              <a:rPr sz="1400" b="1" dirty="0" err="1">
+              <a:rPr sz="1400" b="1">
                 <a:solidFill>
                   <a:srgbClr val="0F172A"/>
                 </a:solidFill>
                 <a:latin typeface="Pretendard"/>
               </a:rPr>
-              <a:t>근무지</a:t>
-            </a:r>
-            <a:r>
-              <a:rPr sz="1400" b="1" dirty="0">
-                <a:solidFill>
-                  <a:srgbClr val="0F172A"/>
-                </a:solidFill>
-                <a:latin typeface="Pretendard"/>
-              </a:rPr>
-              <a:t> 칩 — </a:t>
-            </a:r>
-            <a:r>
-              <a:rPr sz="1400" b="1" dirty="0" err="1">
-                <a:solidFill>
-                  <a:srgbClr val="0F172A"/>
-                </a:solidFill>
-                <a:latin typeface="Pretendard"/>
-              </a:rPr>
-              <a:t>사무실</a:t>
-            </a:r>
-            <a:r>
-              <a:rPr sz="1400" b="1" dirty="0">
-                <a:solidFill>
-                  <a:srgbClr val="0F172A"/>
-                </a:solidFill>
-                <a:latin typeface="Pretendard"/>
-              </a:rPr>
-              <a:t> / </a:t>
-            </a:r>
-            <a:r>
-              <a:rPr sz="1400" b="1" dirty="0" err="1">
-                <a:solidFill>
-                  <a:srgbClr val="0F172A"/>
-                </a:solidFill>
-                <a:latin typeface="Pretendard"/>
-              </a:rPr>
-              <a:t>재택</a:t>
-            </a:r>
-            <a:r>
-              <a:rPr sz="1400" b="1" dirty="0">
-                <a:solidFill>
-                  <a:srgbClr val="0F172A"/>
-                </a:solidFill>
-                <a:latin typeface="Pretendard"/>
-              </a:rPr>
-              <a:t> / </a:t>
-            </a:r>
-            <a:r>
-              <a:rPr sz="1400" b="1" dirty="0" err="1">
-                <a:solidFill>
-                  <a:srgbClr val="0F172A"/>
-                </a:solidFill>
-                <a:latin typeface="Pretendard"/>
-              </a:rPr>
-              <a:t>외근</a:t>
-            </a:r>
-            <a:r>
-              <a:rPr sz="1400" b="1" dirty="0">
-                <a:solidFill>
-                  <a:srgbClr val="0F172A"/>
-                </a:solidFill>
-                <a:latin typeface="Pretendard"/>
-              </a:rPr>
-              <a:t> / </a:t>
-            </a:r>
-            <a:r>
-              <a:rPr sz="1400" b="1" dirty="0" err="1">
-                <a:solidFill>
-                  <a:srgbClr val="0F172A"/>
-                </a:solidFill>
-                <a:latin typeface="Pretendard"/>
-              </a:rPr>
-              <a:t>기타</a:t>
-            </a:r>
-            <a:endParaRPr sz="1400" b="1" dirty="0">
-              <a:solidFill>
-                <a:srgbClr val="0F172A"/>
-              </a:solidFill>
-              <a:latin typeface="Pretendard"/>
-            </a:endParaRPr>
+              <a:t>근무지 칩 — 사무실 / 재택 / 외근 / 기타</a:t>
+            </a:r>
           </a:p>
         </p:txBody>
       </p:sp>
@@ -16840,83 +16378,14 @@
               </a:lnSpc>
             </a:pPr>
             <a:r>
-              <a:rPr sz="1100" b="0" dirty="0">
+              <a:rPr sz="1100" b="0">
                 <a:solidFill>
                   <a:srgbClr val="64748B"/>
                 </a:solidFill>
                 <a:latin typeface="Pretendard"/>
               </a:rPr>
-              <a:t>한 줄 </a:t>
-            </a:r>
-            <a:r>
-              <a:rPr sz="1100" b="0" dirty="0" err="1">
-                <a:solidFill>
-                  <a:srgbClr val="64748B"/>
-                </a:solidFill>
-                <a:latin typeface="Pretendard"/>
-              </a:rPr>
-              <a:t>추가</a:t>
-            </a:r>
-            <a:r>
-              <a:rPr sz="1100" b="0" dirty="0">
-                <a:solidFill>
-                  <a:srgbClr val="64748B"/>
-                </a:solidFill>
-                <a:latin typeface="Pretendard"/>
-              </a:rPr>
-              <a:t> + ★로 </a:t>
-            </a:r>
-            <a:r>
-              <a:rPr sz="1100" b="0" dirty="0" err="1">
-                <a:solidFill>
-                  <a:srgbClr val="64748B"/>
-                </a:solidFill>
-                <a:latin typeface="Pretendard"/>
-              </a:rPr>
-              <a:t>현재</a:t>
-            </a:r>
-            <a:r>
-              <a:rPr sz="1100" b="0" dirty="0">
-                <a:solidFill>
-                  <a:srgbClr val="64748B"/>
-                </a:solidFill>
-                <a:latin typeface="Pretendard"/>
-              </a:rPr>
-              <a:t> </a:t>
-            </a:r>
-            <a:r>
-              <a:rPr sz="1100" b="0" dirty="0" err="1">
-                <a:solidFill>
-                  <a:srgbClr val="64748B"/>
-                </a:solidFill>
-                <a:latin typeface="Pretendard"/>
-              </a:rPr>
-              <a:t>위치</a:t>
-            </a:r>
-            <a:r>
-              <a:rPr sz="1100" b="0" dirty="0">
-                <a:solidFill>
-                  <a:srgbClr val="64748B"/>
-                </a:solidFill>
-                <a:latin typeface="Pretendard"/>
-              </a:rPr>
-              <a:t> </a:t>
-            </a:r>
-            <a:r>
-              <a:rPr sz="1100" b="0" dirty="0" err="1">
-                <a:solidFill>
-                  <a:srgbClr val="64748B"/>
-                </a:solidFill>
-                <a:latin typeface="Pretendard"/>
-              </a:rPr>
-              <a:t>마커</a:t>
-            </a:r>
-            <a:endParaRPr sz="1100" b="0" dirty="0">
-              <a:solidFill>
-                <a:srgbClr val="64748B"/>
-              </a:solidFill>
-              <a:latin typeface="Pretendard"/>
-            </a:endParaRPr>
+              <a:t>한 줄 추가 + ★로 현재 위치 마커</a:t>
+            </a:r>
           </a:p>
         </p:txBody>
       </p:sp>
@@ -17014,7 +16483,7 @@
         <p:spPr>
           <a:xfrm>
             <a:off x="1325880" y="4343400"/>
-            <a:ext cx="5120640" cy="237437"/>
+            <a:ext cx="5120640" cy="365760"/>
           </a:xfrm>
           <a:prstGeom prst="rect">
             <a:avLst/>
@@ -17033,20 +16502,14 @@
               </a:lnSpc>
             </a:pPr>
             <a:r>
-              <a:rPr lang="ko-KR" altLang="en-US" sz="1400" b="1" dirty="0">
+              <a:rPr sz="1400" b="1">
                 <a:solidFill>
                   <a:srgbClr val="0F172A"/>
                 </a:solidFill>
                 <a:latin typeface="Pretendard"/>
               </a:rPr>
-              <a:t>매일 출근 보고 리마인드 알림 발송</a:t>
-            </a:r>
-            <a:endParaRPr sz="1400" b="1" dirty="0">
-              <a:solidFill>
-                <a:srgbClr val="0F172A"/>
-              </a:solidFill>
-              <a:latin typeface="Pretendard"/>
-            </a:endParaRPr>
+              <a:t>새벽 근무 후엔 어제 날짜로 이동해서 보고</a:t>
+            </a:r>
           </a:p>
         </p:txBody>
       </p:sp>
@@ -17059,7 +16522,7 @@
         <p:spPr>
           <a:xfrm>
             <a:off x="1325880" y="4690872"/>
-            <a:ext cx="5120640" cy="186590"/>
+            <a:ext cx="5120640" cy="365760"/>
           </a:xfrm>
           <a:prstGeom prst="rect">
             <a:avLst/>
@@ -17078,29 +16541,14 @@
               </a:lnSpc>
             </a:pPr>
             <a:r>
-              <a:rPr lang="ko-KR" altLang="en-US" sz="1100" b="0" dirty="0" err="1">
+              <a:rPr sz="1100" b="0">
                 <a:solidFill>
                   <a:srgbClr val="64748B"/>
                 </a:solidFill>
                 <a:latin typeface="Pretendard"/>
               </a:rPr>
-              <a:t>미보고</a:t>
-            </a:r>
-            <a:r>
-              <a:rPr lang="ko-KR" altLang="en-US" sz="1100" b="0" dirty="0">
-                <a:solidFill>
-                  <a:srgbClr val="64748B"/>
-                </a:solidFill>
-                <a:latin typeface="Pretendard"/>
-              </a:rPr>
-              <a:t> 시 알림 발송</a:t>
-            </a:r>
-            <a:endParaRPr sz="1100" b="0" dirty="0">
-              <a:solidFill>
-                <a:srgbClr val="64748B"/>
-              </a:solidFill>
-              <a:latin typeface="Pretendard"/>
-            </a:endParaRPr>
+              <a:t>MY PAGE 헤더의 날짜 chevron 사용</a:t>
+            </a:r>
           </a:p>
         </p:txBody>
       </p:sp>
@@ -21646,7 +21094,7 @@
                 </a:solidFill>
                 <a:latin typeface="Pretendard"/>
               </a:rPr>
-              <a:t>휴가 / 반차 입력</a:t>
+              <a:t>휴가 / 반차 자동 인식</a:t>
             </a:r>
           </a:p>
         </p:txBody>
@@ -21685,7 +21133,7 @@
                 </a:solidFill>
                 <a:latin typeface="Pretendard"/>
               </a:rPr>
-              <a:t>퇴근보고 모달의 "휴가/반차" 섹션에서 입력 → 휴가상신 페이지 자동 이동</a:t>
+              <a:t>본부별 캘린더 시트 1시간마다 자동 동기화 — N-Click 별도 입력 불필요</a:t>
             </a:r>
           </a:p>
         </p:txBody>
@@ -22822,8 +22270,8 @@
         </p:nvSpPr>
         <p:spPr>
           <a:xfrm>
-            <a:off x="868680" y="6079129"/>
-            <a:ext cx="10515600" cy="186141"/>
+            <a:off x="868680" y="5943600"/>
+            <a:ext cx="10515600" cy="457200"/>
           </a:xfrm>
           <a:prstGeom prst="rect">
             <a:avLst/>
@@ -22842,170 +22290,14 @@
               </a:lnSpc>
             </a:pPr>
             <a:r>
-              <a:rPr sz="1100" b="0" dirty="0">
+              <a:rPr sz="1100" b="0">
                 <a:solidFill>
                   <a:srgbClr val="1E40AF"/>
                 </a:solidFill>
                 <a:latin typeface="Pretendard"/>
               </a:rPr>
-              <a:t>💡  </a:t>
-            </a:r>
-            <a:r>
-              <a:rPr sz="1100" b="0" dirty="0" err="1">
-                <a:solidFill>
-                  <a:srgbClr val="1E40AF"/>
-                </a:solidFill>
-                <a:latin typeface="Pretendard"/>
-              </a:rPr>
-              <a:t>휴가</a:t>
-            </a:r>
-            <a:r>
-              <a:rPr sz="1100" b="0" dirty="0">
-                <a:solidFill>
-                  <a:srgbClr val="1E40AF"/>
-                </a:solidFill>
-                <a:latin typeface="Pretendard"/>
-              </a:rPr>
-              <a:t>/</a:t>
-            </a:r>
-            <a:r>
-              <a:rPr sz="1100" b="0" dirty="0" err="1">
-                <a:solidFill>
-                  <a:srgbClr val="1E40AF"/>
-                </a:solidFill>
-                <a:latin typeface="Pretendard"/>
-              </a:rPr>
-              <a:t>반차</a:t>
-            </a:r>
-            <a:r>
-              <a:rPr sz="1100" b="0" dirty="0">
-                <a:solidFill>
-                  <a:srgbClr val="1E40AF"/>
-                </a:solidFill>
-                <a:latin typeface="Pretendard"/>
-              </a:rPr>
-              <a:t> </a:t>
-            </a:r>
-            <a:r>
-              <a:rPr sz="1100" b="0" dirty="0" err="1">
-                <a:solidFill>
-                  <a:srgbClr val="1E40AF"/>
-                </a:solidFill>
-                <a:latin typeface="Pretendard"/>
-              </a:rPr>
-              <a:t>등록</a:t>
-            </a:r>
-            <a:r>
-              <a:rPr sz="1100" b="0" dirty="0">
-                <a:solidFill>
-                  <a:srgbClr val="1E40AF"/>
-                </a:solidFill>
-                <a:latin typeface="Pretendard"/>
-              </a:rPr>
-              <a:t> 후 </a:t>
-            </a:r>
-            <a:r>
-              <a:rPr sz="1100" b="0" dirty="0" err="1">
-                <a:solidFill>
-                  <a:srgbClr val="1E40AF"/>
-                </a:solidFill>
-                <a:latin typeface="Pretendard"/>
-              </a:rPr>
-              <a:t>휴가상신</a:t>
-            </a:r>
-            <a:r>
-              <a:rPr sz="1100" b="0" dirty="0">
-                <a:solidFill>
-                  <a:srgbClr val="1E40AF"/>
-                </a:solidFill>
-                <a:latin typeface="Pretendard"/>
-              </a:rPr>
-              <a:t> </a:t>
-            </a:r>
-            <a:r>
-              <a:rPr sz="1100" b="0" dirty="0" err="1">
-                <a:solidFill>
-                  <a:srgbClr val="1E40AF"/>
-                </a:solidFill>
-                <a:latin typeface="Pretendard"/>
-              </a:rPr>
-              <a:t>페이지로</a:t>
-            </a:r>
-            <a:r>
-              <a:rPr sz="1100" b="0" dirty="0">
-                <a:solidFill>
-                  <a:srgbClr val="1E40AF"/>
-                </a:solidFill>
-                <a:latin typeface="Pretendard"/>
-              </a:rPr>
-              <a:t> </a:t>
-            </a:r>
-            <a:r>
-              <a:rPr sz="1100" b="0" dirty="0" err="1">
-                <a:solidFill>
-                  <a:srgbClr val="1E40AF"/>
-                </a:solidFill>
-                <a:latin typeface="Pretendard"/>
-              </a:rPr>
-              <a:t>자동</a:t>
-            </a:r>
-            <a:r>
-              <a:rPr sz="1100" b="0" dirty="0">
-                <a:solidFill>
-                  <a:srgbClr val="1E40AF"/>
-                </a:solidFill>
-                <a:latin typeface="Pretendard"/>
-              </a:rPr>
-              <a:t> </a:t>
-            </a:r>
-            <a:r>
-              <a:rPr sz="1100" b="0" dirty="0" err="1">
-                <a:solidFill>
-                  <a:srgbClr val="1E40AF"/>
-                </a:solidFill>
-                <a:latin typeface="Pretendard"/>
-              </a:rPr>
-              <a:t>연결</a:t>
-            </a:r>
-            <a:r>
-              <a:rPr sz="1100" b="0" dirty="0">
-                <a:solidFill>
-                  <a:srgbClr val="1E40AF"/>
-                </a:solidFill>
-                <a:latin typeface="Pretendard"/>
-              </a:rPr>
-              <a:t> — </a:t>
-            </a:r>
-            <a:r>
-              <a:rPr lang="ko-KR" altLang="en-US" sz="1100" b="0" dirty="0">
-                <a:solidFill>
-                  <a:srgbClr val="1E40AF"/>
-                </a:solidFill>
-                <a:latin typeface="Pretendard Light" panose="02000403000000020004" pitchFamily="50" charset="-127"/>
-                <a:ea typeface="Pretendard Light" panose="02000403000000020004" pitchFamily="50" charset="-127"/>
-                <a:cs typeface="Pretendard Light" panose="02000403000000020004" pitchFamily="50" charset="-127"/>
-              </a:rPr>
-              <a:t>이동 </a:t>
-            </a:r>
-            <a:r>
-              <a:rPr lang="ko-KR" altLang="en-US" sz="1100" dirty="0">
-                <a:solidFill>
-                  <a:srgbClr val="1E40AF"/>
-                </a:solidFill>
-                <a:latin typeface="Pretendard Light" panose="02000403000000020004" pitchFamily="50" charset="-127"/>
-                <a:ea typeface="Pretendard Light" panose="02000403000000020004" pitchFamily="50" charset="-127"/>
-                <a:cs typeface="Pretendard Light" panose="02000403000000020004" pitchFamily="50" charset="-127"/>
-              </a:rPr>
-              <a:t>시간 단축</a:t>
-            </a:r>
-            <a:endParaRPr sz="1100" b="0" dirty="0">
-              <a:solidFill>
-                <a:srgbClr val="1E40AF"/>
-              </a:solidFill>
-              <a:latin typeface="Pretendard Light" panose="02000403000000020004" pitchFamily="50" charset="-127"/>
-              <a:ea typeface="Pretendard Light" panose="02000403000000020004" pitchFamily="50" charset="-127"/>
-              <a:cs typeface="Pretendard Light" panose="02000403000000020004" pitchFamily="50" charset="-127"/>
-            </a:endParaRPr>
+              <a:t>💡  장기휴가/당일휴가는 N-Click 보고 불필요 — EW상신만 잘 해주세요. 캘린더 등록만 하면 OK</a:t>
+            </a:r>
           </a:p>
         </p:txBody>
       </p:sp>

</xml_diff>